<commit_message>
Fase 2: Informe de Avance, SRS y Documento de Diseño; Fase 1 en cascada
- Fase 2: Informe de Avance (2.4) y los adjuntos A (SRS v0.2) y B (Documento de Diseño v0.2), exportados a Word.
- Fase 1: se reemplazan la Definición de Proyecto, la Carta Gantt y la Presentación por las versiones con metodología en cascada (antes decían Scrum adaptado).
- README: el estado de la Fase 2 pasa a En curso y deja de mencionar Scrum.

Co-Authored-By: Claude Sonnet 5.5 <noreply@anthropic.com>
</commit_message>
<xml_diff>
--- a/Fase 1/Presentacion_SIRFA.pptx
+++ b/Fase 1/Presentacion_SIRFA.pptx
@@ -791,7 +791,7 @@
           <a:lstStyle/>
           <a:p>
             <a:r>
-              <a:t>Leer el objetivo general completo y pausado. Los especificos, de corrido.</a:t>
+              <a:t>Leer el objetivo general completo y pausado: abarca el proceso entero, desde el registro del aislado hasta la recomendación validada y la información para vigilancia. Los especificos, de corrido.</a:t>
             </a:r>
           </a:p>
         </p:txBody>
@@ -1001,7 +1001,7 @@
           <a:lstStyle/>
           <a:p>
             <a:r>
-              <a:t>El cronograma sigue el calendario oficial del curso. Mencionar brevemente el riesgo principal, sin extenderse.</a:t>
+              <a:t>La metodologia es cascada tradicional: analisis, diseño, construccion, pruebas y cierre, cada etapa con su entregable y su puerta de control. Los hitos del curso coinciden con el cierre de etapas: el avance de la semana 10 muestra SRS, diseño y pipeline; el informe final de la semana 15 muestra las pruebas. Mencionar brevemente el riesgo principal, sin extenderse.</a:t>
             </a:r>
           </a:p>
         </p:txBody>
@@ -7279,7 +7279,7 @@
                 </a:solidFill>
                 <a:latin typeface="Calibri"/>
               </a:rPr>
-              <a:t>Diseñar, implementar y evaluar una plataforma web que apoye la selección de bacteriófagos candidatos frente a aislados de bacterias multirresistentes, integrando un banco curado de fagos, un modelo de aprendizaje automático de predicción de compatibilidad a nivel de cepa, la gestión trazable del ciclo de solicitudes con control de acceso por rol, y un tablero de apoyo a la vigilancia de cobertura terapéutica.</a:t>
+              <a:t>Diseñar, desarrollar y evaluar una plataforma integral de apoyo a la terapia fágica frente a la antibiorresistencia, que gestione de forma trazable y segura el proceso completo —desde el registro de un aislado bacteriano multirresistente hasta la emisión de una recomendación de bacteriófagos validada por especialistas— y que entregue información agregada para la vigilancia de la resistencia antimicrobiana y la toma de decisiones en salud pública.</a:t>
             </a:r>
           </a:p>
         </p:txBody>
@@ -9844,7 +9844,7 @@
                 </a:solidFill>
                 <a:latin typeface="Calibri"/>
               </a:rPr>
-              <a:t>Ágil adaptado (Scrum, desarrollador único) · 18 semanas, 10 de agosto al 12 de diciembre de 2026</a:t>
+              <a:t>Tradicional en cascada: 5 etapas con puerta de control · 18 semanas, 10 de agosto al 12 de diciembre de 2026</a:t>
             </a:r>
           </a:p>
         </p:txBody>
@@ -9886,7 +9886,7 @@
                 </a:solidFill>
                 <a:latin typeface="Calibri"/>
               </a:rPr>
-              <a:t>Los hitos sumativos del curso funcionan como revisiones de sprint; cada tramo de la Carta Gantt es un sprint con su propio Definition of Done.</a:t>
+              <a:t>Cada etapa termina en un entregable aprobado antes de iniciar la siguiente: SRS, Documento de Diseño, sistema integrado, Plan de Pruebas y Manual técnico.</a:t>
             </a:r>
           </a:p>
         </p:txBody>
@@ -10276,7 +10276,7 @@
                 </a:solidFill>
                 <a:latin typeface="Calibri"/>
               </a:rPr>
-              <a:t>S5–7</a:t>
+              <a:t>S5–6</a:t>
             </a:r>
           </a:p>
         </p:txBody>
@@ -10318,7 +10318,7 @@
                 </a:solidFill>
                 <a:latin typeface="Calibri"/>
               </a:rPr>
-              <a:t>OE1</a:t>
+              <a:t>Análisis (SRS)</a:t>
             </a:r>
           </a:p>
         </p:txBody>
@@ -10406,7 +10406,7 @@
                 </a:solidFill>
                 <a:latin typeface="Calibri"/>
               </a:rPr>
-              <a:t>S8–9</a:t>
+              <a:t>S6–7</a:t>
             </a:r>
           </a:p>
         </p:txBody>
@@ -10448,7 +10448,7 @@
                 </a:solidFill>
                 <a:latin typeface="Calibri"/>
               </a:rPr>
-              <a:t>OE2</a:t>
+              <a:t>Diseño</a:t>
             </a:r>
           </a:p>
         </p:txBody>
@@ -10536,7 +10536,7 @@
                 </a:solidFill>
                 <a:latin typeface="Calibri"/>
               </a:rPr>
-              <a:t>S10</a:t>
+              <a:t>S8–10</a:t>
             </a:r>
           </a:p>
         </p:txBody>
@@ -10578,7 +10578,7 @@
                 </a:solidFill>
                 <a:latin typeface="Calibri"/>
               </a:rPr>
-              <a:t>Avance</a:t>
+              <a:t>Pipeline y banco</a:t>
             </a:r>
           </a:p>
         </p:txBody>
@@ -10750,7 +10750,7 @@
                 </a:solidFill>
                 <a:latin typeface="Calibri"/>
               </a:rPr>
-              <a:t>OE3</a:t>
+              <a:t>Modelo</a:t>
             </a:r>
           </a:p>
         </p:txBody>
@@ -10880,7 +10880,7 @@
                 </a:solidFill>
                 <a:latin typeface="Calibri"/>
               </a:rPr>
-              <a:t>OE4</a:t>
+              <a:t>Web y móvil</a:t>
             </a:r>
           </a:p>
         </p:txBody>
@@ -11010,7 +11010,7 @@
                 </a:solidFill>
                 <a:latin typeface="Calibri"/>
               </a:rPr>
-              <a:t>Final</a:t>
+              <a:t>Pruebas</a:t>
             </a:r>
           </a:p>
         </p:txBody>
@@ -11182,7 +11182,7 @@
                 </a:solidFill>
                 <a:latin typeface="Calibri"/>
               </a:rPr>
-              <a:t>Pulido</a:t>
+              <a:t>Cierre</a:t>
             </a:r>
           </a:p>
         </p:txBody>
@@ -12208,7 +12208,7 @@
                 </a:solidFill>
                 <a:latin typeface="Calibri"/>
               </a:rPr>
-              <a:t>Historias de usuario por rol, RF y RNF.</a:t>
+              <a:t>Historias de usuario por rol, RF, RNF y SRS.</a:t>
             </a:r>
           </a:p>
         </p:txBody>
@@ -12391,7 +12391,7 @@
                 </a:solidFill>
                 <a:latin typeface="Calibri"/>
               </a:rPr>
-              <a:t>Scrum adaptado, sprints, DoD y matriz de riesgos.</a:t>
+              <a:t>Cascada con etapas, entregables y puertas de control; matriz de riesgos.</a:t>
             </a:r>
           </a:p>
         </p:txBody>

</xml_diff>